<commit_message>
Wrap every response in { statusCode, message, data }; errors stay RFC 7807
- MVC result filter wraps success values and model-validation problems;
  a Problem Details writer (registered first) wraps every other error
- Per-action success messages; replayed idempotent requests say so
- 401/403/404/405 get a message and a code; health probes use the envelope
- Logout returns 200 with the envelope instead of 204
- Tests read data through envelope-checking helpers; new tests cover every
  error path and the success shape (150 tests)
- Smoke script, README, testing guide, AI_USAGE and deck updated

Co-Authored-By: Claude Opus 5 <noreply@anthropic.com>
</commit_message>
<xml_diff>
--- a/docs/Ikenna_Odoh_NovaWallet_Case_Study.pptx
+++ b/docs/Ikenna_Odoh_NovaWallet_Case_Study.pptx
@@ -1308,7 +1308,7 @@
           <a:p>
             <a:r>
               <a:rPr lang="en-US" dirty="0"/>
-              <a:t>The headline: 200 transfers fired at the same instant against a thousand-naira wallet — exactly ten succeed, every time, balance lands on zero, and the ledger agrees. 148 tests in total, half of them against real Postgres. All four stretch goals are in, plus real sign-in and an admin flow.</a:t>
+              <a:t>The headline: 200 transfers fired at the same instant against a thousand-naira wallet — exactly ten succeed, every time, balance lands on zero, and the ledger agrees. 150 tests in total, about half of them against real Postgres. All four stretch goals are in, plus real sign-in and an admin flow.</a:t>
             </a:r>
             <a:endParaRPr lang="en-US" dirty="0"/>
           </a:p>
@@ -6713,7 +6713,7 @@
                 <a:ea typeface="Cambria" pitchFamily="34" charset="-122"/>
                 <a:cs typeface="Cambria" pitchFamily="34" charset="-120"/>
               </a:rPr>
-              <a:t>148</a:t>
+              <a:t>150</a:t>
             </a:r>
             <a:endParaRPr lang="en-US" sz="4000" dirty="0"/>
           </a:p>
@@ -6752,7 +6752,7 @@
                 <a:ea typeface="Calibri" pitchFamily="34" charset="-122"/>
                 <a:cs typeface="Calibri" pitchFamily="34" charset="-120"/>
               </a:rPr>
-              <a:t>automated tests: 74 unit + 74 against real PostgreSQL, all green</a:t>
+              <a:t>automated tests: 74 unit + 76 against real PostgreSQL, all green</a:t>
             </a:r>
             <a:endParaRPr lang="en-US" sz="1150" dirty="0"/>
           </a:p>
@@ -7029,7 +7029,7 @@
                 <a:ea typeface="Calibri" pitchFamily="34" charset="-122"/>
                 <a:cs typeface="Calibri" pitchFamily="34" charset="-120"/>
               </a:rPr>
-              <a:t>password sign-in with rotating refresh tokens · admin API (users, freezes, action log) · Swagger/OpenAPI · rate limiting · transactional outbox · Serilog correlation IDs · health probes · hash-chained audit trail · CI with a compose smoke test · README, testing guide, AI_USAGE.md</a:t>
+              <a:t>password sign-in with rotating refresh tokens · admin API (users, freezes, action log) · every response { statusCode, message, data } (errors also RFC 7807) · Swagger · rate limiting · transactional outbox · Serilog correlation IDs · health probes · hash-chained audit trail · CI with a compose smoke test · README, testing guide, AI_USAGE.md</a:t>
             </a:r>
             <a:endParaRPr lang="en-US" sz="1250" dirty="0"/>
           </a:p>

</xml_diff>

<commit_message>
Revert "Wrap every response in { statusCode, message, data }; errors stay RFC 7807"
This reverts commit c3f6655e7471f77bca7e8944d2051daf7d3f00de.
</commit_message>
<xml_diff>
--- a/docs/Ikenna_Odoh_NovaWallet_Case_Study.pptx
+++ b/docs/Ikenna_Odoh_NovaWallet_Case_Study.pptx
@@ -1308,7 +1308,7 @@
           <a:p>
             <a:r>
               <a:rPr lang="en-US" dirty="0"/>
-              <a:t>The headline: 200 transfers fired at the same instant against a thousand-naira wallet — exactly ten succeed, every time, balance lands on zero, and the ledger agrees. 150 tests in total, about half of them against real Postgres. All four stretch goals are in, plus real sign-in and an admin flow.</a:t>
+              <a:t>The headline: 200 transfers fired at the same instant against a thousand-naira wallet — exactly ten succeed, every time, balance lands on zero, and the ledger agrees. 148 tests in total, half of them against real Postgres. All four stretch goals are in, plus real sign-in and an admin flow.</a:t>
             </a:r>
             <a:endParaRPr lang="en-US" dirty="0"/>
           </a:p>
@@ -6713,7 +6713,7 @@
                 <a:ea typeface="Cambria" pitchFamily="34" charset="-122"/>
                 <a:cs typeface="Cambria" pitchFamily="34" charset="-120"/>
               </a:rPr>
-              <a:t>150</a:t>
+              <a:t>148</a:t>
             </a:r>
             <a:endParaRPr lang="en-US" sz="4000" dirty="0"/>
           </a:p>
@@ -6752,7 +6752,7 @@
                 <a:ea typeface="Calibri" pitchFamily="34" charset="-122"/>
                 <a:cs typeface="Calibri" pitchFamily="34" charset="-120"/>
               </a:rPr>
-              <a:t>automated tests: 74 unit + 76 against real PostgreSQL, all green</a:t>
+              <a:t>automated tests: 74 unit + 74 against real PostgreSQL, all green</a:t>
             </a:r>
             <a:endParaRPr lang="en-US" sz="1150" dirty="0"/>
           </a:p>
@@ -7029,7 +7029,7 @@
                 <a:ea typeface="Calibri" pitchFamily="34" charset="-122"/>
                 <a:cs typeface="Calibri" pitchFamily="34" charset="-120"/>
               </a:rPr>
-              <a:t>password sign-in with rotating refresh tokens · admin API (users, freezes, action log) · every response { statusCode, message, data } (errors also RFC 7807) · Swagger · rate limiting · transactional outbox · Serilog correlation IDs · health probes · hash-chained audit trail · CI with a compose smoke test · README, testing guide, AI_USAGE.md</a:t>
+              <a:t>password sign-in with rotating refresh tokens · admin API (users, freezes, action log) · Swagger/OpenAPI · rate limiting · transactional outbox · Serilog correlation IDs · health probes · hash-chained audit trail · CI with a compose smoke test · README, testing guide, AI_USAGE.md</a:t>
             </a:r>
             <a:endParaRPr lang="en-US" sz="1250" dirty="0"/>
           </a:p>

</xml_diff>

<commit_message>
Take the transfer source wallet from the signed-in user
- POST /api/v1/transfers body is now { destinationWalletId, amountKobo,
  narration }; a body naming sourceWalletId is refused (400)
- Caller without a wallet gets 404 with a clear message; ownership check
  kept as defence in depth
- Swagger explains the Idempotency-Key header
- Tests, smoke script, README, testing guide, AI_USAGE and deck updated
  (151 tests)

Co-Authored-By: Claude Opus 5 <noreply@anthropic.com>
</commit_message>
<xml_diff>
--- a/docs/Ikenna_Odoh_NovaWallet_Case_Study.pptx
+++ b/docs/Ikenna_Odoh_NovaWallet_Case_Study.pptx
@@ -1308,7 +1308,7 @@
           <a:p>
             <a:r>
               <a:rPr lang="en-US" dirty="0"/>
-              <a:t>The headline: 200 transfers fired at the same instant against a thousand-naira wallet — exactly ten succeed, every time, balance lands on zero, and the ledger agrees. 148 tests in total, half of them against real Postgres. All four stretch goals are in, plus real sign-in and an admin flow.</a:t>
+              <a:t>The headline: 200 transfers fired at the same instant against a thousand-naira wallet — exactly ten succeed, every time, balance lands on zero, and the ledger agrees. 151 tests in total, about half of them against real Postgres. All four stretch goals are in, plus real sign-in and an admin flow.</a:t>
             </a:r>
             <a:endParaRPr lang="en-US" dirty="0"/>
           </a:p>
@@ -6713,7 +6713,7 @@
                 <a:ea typeface="Cambria" pitchFamily="34" charset="-122"/>
                 <a:cs typeface="Cambria" pitchFamily="34" charset="-120"/>
               </a:rPr>
-              <a:t>148</a:t>
+              <a:t>151</a:t>
             </a:r>
             <a:endParaRPr lang="en-US" sz="4000" dirty="0"/>
           </a:p>
@@ -6752,7 +6752,7 @@
                 <a:ea typeface="Calibri" pitchFamily="34" charset="-122"/>
                 <a:cs typeface="Calibri" pitchFamily="34" charset="-120"/>
               </a:rPr>
-              <a:t>automated tests: 74 unit + 74 against real PostgreSQL, all green</a:t>
+              <a:t>automated tests: 75 unit + 76 against real PostgreSQL, all green</a:t>
             </a:r>
             <a:endParaRPr lang="en-US" sz="1150" dirty="0"/>
           </a:p>
@@ -8939,7 +8939,7 @@
                 <a:ea typeface="Calibri" pitchFamily="34" charset="-122"/>
                 <a:cs typeface="Calibri" pitchFamily="34" charset="-120"/>
               </a:rPr>
-              <a:t>owner · funds · daily limit — all while holding the locks</a:t>
+              <a:t>source = your own wallet · funds · daily limit — under the locks</a:t>
             </a:r>
             <a:endParaRPr lang="en-US" sz="1000" dirty="0"/>
           </a:p>
@@ -13674,7 +13674,7 @@
                 <a:ea typeface="Calibri" pitchFamily="34" charset="-122"/>
                 <a:cs typeface="Calibri" pitchFamily="34" charset="-120"/>
               </a:rPr>
-              <a:t>Other customers' wallets return 404; receipts show only the sender's balance</a:t>
+              <a:t>Source wallet comes from the token; others' wallets return 404; receipts show only the sender's balance</a:t>
             </a:r>
             <a:endParaRPr lang="en-US" sz="1000" dirty="0"/>
           </a:p>

</xml_diff>

<commit_message>
Accept customerId in any GUID format when creating a wallet
Fixes a 403/400 that hit any caller who copied a userId from the API's
own output (GET /me, GET /admin/users) into the wallet-creation body:
Guid values are shown with dashes everywhere, but customerId was only
compared against the dashless JWT-subject format via string equality.

- WalletService.CreateAsync now parses customerId with Guid.TryParse
  (accepts dashed and dashless) and resolves/compares by GUID value
- Removed the now-unused strict-format validator (RequestGuard.CustomerId)
- New tests: dashed customerId accepted for self and for an admin
  assigning another user's wallet; malformed customerId still 400
- Confirmed the new test fails without the fix (reverted to
  Guid.TryParseExact 'N' locally, re-ran, restored)
- Docs, smoke/testing guide, and deck updated (153 tests: 75 unit + 78
  integration)

Co-Authored-By: Claude Sonnet 5 <noreply@anthropic.com>
</commit_message>
<xml_diff>
--- a/docs/Ikenna_Odoh_NovaWallet_Case_Study.pptx
+++ b/docs/Ikenna_Odoh_NovaWallet_Case_Study.pptx
@@ -1308,7 +1308,7 @@
           <a:p>
             <a:r>
               <a:rPr lang="en-US" dirty="0"/>
-              <a:t>The headline: 200 transfers fired at the same instant against a thousand-naira wallet — exactly ten succeed, every time, balance lands on zero, and the ledger agrees. 151 tests in total, about half of them against real Postgres. All four stretch goals are in, plus real sign-in and an admin flow.</a:t>
+              <a:t>The headline: 200 transfers fired at the same instant against a thousand-naira wallet — exactly ten succeed, every time, balance lands on zero, and the ledger agrees. 153 tests in total, about half of them against real Postgres. All four stretch goals are in, plus real sign-in and an admin flow.</a:t>
             </a:r>
             <a:endParaRPr lang="en-US" dirty="0"/>
           </a:p>
@@ -6713,7 +6713,7 @@
                 <a:ea typeface="Cambria" pitchFamily="34" charset="-122"/>
                 <a:cs typeface="Cambria" pitchFamily="34" charset="-120"/>
               </a:rPr>
-              <a:t>151</a:t>
+              <a:t>153</a:t>
             </a:r>
             <a:endParaRPr lang="en-US" sz="4000" dirty="0"/>
           </a:p>
@@ -6752,7 +6752,7 @@
                 <a:ea typeface="Calibri" pitchFamily="34" charset="-122"/>
                 <a:cs typeface="Calibri" pitchFamily="34" charset="-120"/>
               </a:rPr>
-              <a:t>automated tests: 75 unit + 76 against real PostgreSQL, all green</a:t>
+              <a:t>automated tests: 75 unit + 78 against real PostgreSQL, all green</a:t>
             </a:r>
             <a:endParaRPr lang="en-US" sz="1150" dirty="0"/>
           </a:p>

</xml_diff>

<commit_message>
Add GET /api/v1/admin/wallets to browse and filter every wallet
Previously 'view any wallet' only meant look up one wallet by id, or
find a customer's walletId via GET /admin/users?email=. There was no
way to browse or filter the whole wallet table (e.g. review every
wallet currently on hold), which is a real gap for an admin/ops tool.

- ILedgerStore.ListWalletsAsync + LedgerStore implementation, keyset
  paginated by wallet id, optional status filter (active|frozen)
- AdminService.ListWalletsAsync / WalletPage contract, mirroring the
  existing ListUsersAsync/ListActionsAsync pagination pattern
- AdminController: GET /api/v1/admin/wallets?status=&limit=&cursor=
- New tests: status filtering (with a mutation check confirming it's
  exercised), pagination mechanics (no gaps/duplicates), access control
- Smoke script, README, testing guide, AI_USAGE and deck updated
  (156 tests: 75 unit + 81 integration)

Co-Authored-By: Claude Sonnet 5 <noreply@anthropic.com>
</commit_message>
<xml_diff>
--- a/docs/Ikenna_Odoh_NovaWallet_Case_Study.pptx
+++ b/docs/Ikenna_Odoh_NovaWallet_Case_Study.pptx
@@ -1308,7 +1308,7 @@
           <a:p>
             <a:r>
               <a:rPr lang="en-US" dirty="0"/>
-              <a:t>The headline: 200 transfers fired at the same instant against a thousand-naira wallet — exactly ten succeed, every time, balance lands on zero, and the ledger agrees. 153 tests in total, about half of them against real Postgres. All four stretch goals are in, plus real sign-in and an admin flow.</a:t>
+              <a:t>The headline: 200 transfers fired at the same instant against a thousand-naira wallet — exactly ten succeed, every time, balance lands on zero, and the ledger agrees. 156 tests in total, about half of them against real Postgres. All four stretch goals are in, plus real sign-in and an admin flow.</a:t>
             </a:r>
             <a:endParaRPr lang="en-US" dirty="0"/>
           </a:p>
@@ -6713,7 +6713,7 @@
                 <a:ea typeface="Cambria" pitchFamily="34" charset="-122"/>
                 <a:cs typeface="Cambria" pitchFamily="34" charset="-120"/>
               </a:rPr>
-              <a:t>153</a:t>
+              <a:t>156</a:t>
             </a:r>
             <a:endParaRPr lang="en-US" sz="4000" dirty="0"/>
           </a:p>
@@ -6752,7 +6752,7 @@
                 <a:ea typeface="Calibri" pitchFamily="34" charset="-122"/>
                 <a:cs typeface="Calibri" pitchFamily="34" charset="-120"/>
               </a:rPr>
-              <a:t>automated tests: 75 unit + 78 against real PostgreSQL, all green</a:t>
+              <a:t>automated tests: 75 unit + 81 against real PostgreSQL, all green</a:t>
             </a:r>
             <a:endParaRPr lang="en-US" sz="1150" dirty="0"/>
           </a:p>
@@ -12919,7 +12919,7 @@
                 <a:ea typeface="Calibri" pitchFamily="34" charset="-122"/>
                 <a:cs typeface="Calibri" pitchFamily="34" charset="-120"/>
               </a:rPr>
-              <a:t>View any wallet</a:t>
+              <a:t>View &amp; browse wallets</a:t>
             </a:r>
             <a:endParaRPr lang="en-US" sz="1150" dirty="0"/>
           </a:p>
@@ -12958,7 +12958,7 @@
                 <a:ea typeface="Calibri" pitchFamily="34" charset="-122"/>
                 <a:cs typeface="Calibri" pitchFamily="34" charset="-120"/>
               </a:rPr>
-              <a:t>find a user, see balance and statement</a:t>
+              <a:t>look up any wallet; filter the full list by status</a:t>
             </a:r>
             <a:endParaRPr lang="en-US" sz="950" dirty="0"/>
           </a:p>

</xml_diff>